<commit_message>
made some changes in all ppts
</commit_message>
<xml_diff>
--- a/church/church ppts/lords table/Purpose of Incarnation of Christ.pptx
+++ b/church/church ppts/lords table/Purpose of Incarnation of Christ.pptx
@@ -106,6 +106,11 @@
       </a:defRPr>
     </a:lvl9pPr>
   </p:defaultTextStyle>
+  <p:extLst>
+    <p:ext uri="{EFAFB233-063F-42B5-8137-9DF3F51BA10A}">
+      <p15:sldGuideLst xmlns:p15="http://schemas.microsoft.com/office/powerpoint/2012/main"/>
+    </p:ext>
+  </p:extLst>
 </p:presentation>
 </file>
 
@@ -295,7 +300,7 @@
           <a:p>
             <a:fld id="{4AAD347D-5ACD-4C99-B74B-A9C85AD731AF}" type="datetimeFigureOut">
               <a:rPr lang="en-US" dirty="0"/>
-              <a:t>5/24/2026</a:t>
+              <a:t>8/18/2026</a:t>
             </a:fld>
             <a:endParaRPr lang="en-US" dirty="0"/>
           </a:p>
@@ -565,7 +570,7 @@
           <a:p>
             <a:fld id="{4509A250-FF31-4206-8172-F9D3106AACB1}" type="datetimeFigureOut">
               <a:rPr lang="en-US" dirty="0"/>
-              <a:t>5/24/2026</a:t>
+              <a:t>8/18/2026</a:t>
             </a:fld>
             <a:endParaRPr lang="en-US" dirty="0"/>
           </a:p>
@@ -754,7 +759,7 @@
           <a:p>
             <a:fld id="{4509A250-FF31-4206-8172-F9D3106AACB1}" type="datetimeFigureOut">
               <a:rPr lang="en-US" dirty="0"/>
-              <a:t>5/24/2026</a:t>
+              <a:t>8/18/2026</a:t>
             </a:fld>
             <a:endParaRPr lang="en-US" dirty="0"/>
           </a:p>
@@ -1020,7 +1025,7 @@
           <a:p>
             <a:fld id="{4509A250-FF31-4206-8172-F9D3106AACB1}" type="datetimeFigureOut">
               <a:rPr lang="en-US" dirty="0"/>
-              <a:t>5/24/2026</a:t>
+              <a:t>8/18/2026</a:t>
             </a:fld>
             <a:endParaRPr lang="en-US" dirty="0"/>
           </a:p>
@@ -1342,7 +1347,7 @@
           <a:p>
             <a:fld id="{4509A250-FF31-4206-8172-F9D3106AACB1}" type="datetimeFigureOut">
               <a:rPr lang="en-US" dirty="0"/>
-              <a:t>5/24/2026</a:t>
+              <a:t>8/18/2026</a:t>
             </a:fld>
             <a:endParaRPr lang="en-US" dirty="0"/>
           </a:p>
@@ -1956,7 +1961,7 @@
           <a:p>
             <a:fld id="{4509A250-FF31-4206-8172-F9D3106AACB1}" type="datetimeFigureOut">
               <a:rPr lang="en-US" dirty="0"/>
-              <a:t>5/24/2026</a:t>
+              <a:t>8/18/2026</a:t>
             </a:fld>
             <a:endParaRPr lang="en-US" dirty="0"/>
           </a:p>
@@ -2798,7 +2803,7 @@
           <a:p>
             <a:fld id="{4509A250-FF31-4206-8172-F9D3106AACB1}" type="datetimeFigureOut">
               <a:rPr lang="en-US" dirty="0"/>
-              <a:t>5/24/2026</a:t>
+              <a:t>8/18/2026</a:t>
             </a:fld>
             <a:endParaRPr lang="en-US" dirty="0"/>
           </a:p>
@@ -2963,7 +2968,7 @@
           <a:p>
             <a:fld id="{4509A250-FF31-4206-8172-F9D3106AACB1}" type="datetimeFigureOut">
               <a:rPr lang="en-US" dirty="0"/>
-              <a:t>5/24/2026</a:t>
+              <a:t>8/18/2026</a:t>
             </a:fld>
             <a:endParaRPr lang="en-US" dirty="0"/>
           </a:p>
@@ -3138,7 +3143,7 @@
           <a:p>
             <a:fld id="{4509A250-FF31-4206-8172-F9D3106AACB1}" type="datetimeFigureOut">
               <a:rPr lang="en-US" dirty="0"/>
-              <a:t>5/24/2026</a:t>
+              <a:t>8/18/2026</a:t>
             </a:fld>
             <a:endParaRPr lang="en-US" dirty="0"/>
           </a:p>
@@ -3303,7 +3308,7 @@
           <a:p>
             <a:fld id="{9796027F-7875-4030-9381-8BD8C4F21935}" type="datetimeFigureOut">
               <a:rPr lang="en-US" dirty="0"/>
-              <a:t>5/24/2026</a:t>
+              <a:t>8/18/2026</a:t>
             </a:fld>
             <a:endParaRPr lang="en-US" dirty="0"/>
           </a:p>
@@ -3545,7 +3550,7 @@
           <a:p>
             <a:fld id="{9796027F-7875-4030-9381-8BD8C4F21935}" type="datetimeFigureOut">
               <a:rPr lang="en-US" dirty="0"/>
-              <a:t>5/24/2026</a:t>
+              <a:t>8/18/2026</a:t>
             </a:fld>
             <a:endParaRPr lang="en-US" dirty="0"/>
           </a:p>
@@ -3832,7 +3837,7 @@
           <a:p>
             <a:fld id="{9796027F-7875-4030-9381-8BD8C4F21935}" type="datetimeFigureOut">
               <a:rPr lang="en-US" dirty="0"/>
-              <a:t>5/24/2026</a:t>
+              <a:t>8/18/2026</a:t>
             </a:fld>
             <a:endParaRPr lang="en-US" dirty="0"/>
           </a:p>
@@ -4271,7 +4276,7 @@
           <a:p>
             <a:fld id="{9796027F-7875-4030-9381-8BD8C4F21935}" type="datetimeFigureOut">
               <a:rPr lang="en-US" dirty="0"/>
-              <a:t>5/24/2026</a:t>
+              <a:t>8/18/2026</a:t>
             </a:fld>
             <a:endParaRPr lang="en-US" dirty="0"/>
           </a:p>
@@ -4384,7 +4389,7 @@
           <a:p>
             <a:fld id="{4509A250-FF31-4206-8172-F9D3106AACB1}" type="datetimeFigureOut">
               <a:rPr lang="en-US" dirty="0"/>
-              <a:t>5/24/2026</a:t>
+              <a:t>8/18/2026</a:t>
             </a:fld>
             <a:endParaRPr lang="en-US" dirty="0"/>
           </a:p>
@@ -4474,7 +4479,7 @@
           <a:p>
             <a:fld id="{4509A250-FF31-4206-8172-F9D3106AACB1}" type="datetimeFigureOut">
               <a:rPr lang="en-US" dirty="0"/>
-              <a:t>5/24/2026</a:t>
+              <a:t>8/18/2026</a:t>
             </a:fld>
             <a:endParaRPr lang="en-US" dirty="0"/>
           </a:p>
@@ -4748,7 +4753,7 @@
           <a:p>
             <a:fld id="{4509A250-FF31-4206-8172-F9D3106AACB1}" type="datetimeFigureOut">
               <a:rPr lang="en-US" dirty="0"/>
-              <a:t>5/24/2026</a:t>
+              <a:t>8/18/2026</a:t>
             </a:fld>
             <a:endParaRPr lang="en-US" dirty="0"/>
           </a:p>
@@ -5018,7 +5023,7 @@
           <a:p>
             <a:fld id="{4509A250-FF31-4206-8172-F9D3106AACB1}" type="datetimeFigureOut">
               <a:rPr lang="en-US" dirty="0"/>
-              <a:t>5/24/2026</a:t>
+              <a:t>8/18/2026</a:t>
             </a:fld>
             <a:endParaRPr lang="en-US" dirty="0"/>
           </a:p>
@@ -5436,7 +5441,7 @@
           <a:p>
             <a:fld id="{4AAD347D-5ACD-4C99-B74B-A9C85AD731AF}" type="datetimeFigureOut">
               <a:rPr lang="en-US" dirty="0"/>
-              <a:t>5/24/2026</a:t>
+              <a:t>8/18/2026</a:t>
             </a:fld>
             <a:endParaRPr lang="en-US" dirty="0"/>
           </a:p>
@@ -6102,17 +6107,8 @@
             </a:pPr>
             <a:r>
               <a:rPr lang="en-US" sz="2400" b="1" dirty="0" smtClean="0"/>
-              <a:t>Remission Of </a:t>
-            </a:r>
-            <a:r>
-              <a:rPr lang="en-US" sz="2400" b="1" dirty="0" smtClean="0"/>
-              <a:t>Sin    :    Mark </a:t>
-            </a:r>
-            <a:r>
-              <a:rPr lang="en-US" sz="2400" b="1" dirty="0" smtClean="0"/>
-              <a:t>10:45, </a:t>
-            </a:r>
-            <a:endParaRPr lang="en-US" sz="2400" b="1" dirty="0" smtClean="0"/>
+              <a:t>Remission Of Sin    :    Mark 10:45, </a:t>
+            </a:r>
           </a:p>
           <a:p>
             <a:pPr marL="457200" indent="-457200">
@@ -6165,7 +6161,6 @@
               <a:rPr lang="en-US" sz="2400" b="1" dirty="0" smtClean="0"/>
               <a:t>3,4</a:t>
             </a:r>
-            <a:endParaRPr lang="en-US" sz="2400" b="1" dirty="0" smtClean="0"/>
           </a:p>
           <a:p>
             <a:pPr marL="457200" indent="-457200">
@@ -6174,23 +6169,7 @@
             </a:pPr>
             <a:r>
               <a:rPr lang="en-US" sz="2400" b="1" dirty="0" smtClean="0"/>
-              <a:t>To confirm the promises made unto the </a:t>
-            </a:r>
-            <a:r>
-              <a:rPr lang="en-US" sz="2400" b="1" dirty="0" smtClean="0"/>
-              <a:t>fathers    </a:t>
-            </a:r>
-            <a:r>
-              <a:rPr lang="en-US" sz="2400" b="1" dirty="0" smtClean="0"/>
-              <a:t>: </a:t>
-            </a:r>
-            <a:r>
-              <a:rPr lang="en-US" sz="2400" b="1" dirty="0" smtClean="0"/>
-              <a:t>   Rom </a:t>
-            </a:r>
-            <a:r>
-              <a:rPr lang="en-US" sz="2400" b="1" dirty="0" smtClean="0"/>
-              <a:t>15:8</a:t>
+              <a:t>To confirm the promises made unto the fathers    :    Rom 15:8</a:t>
             </a:r>
           </a:p>
           <a:p>
@@ -6200,19 +6179,7 @@
             </a:pPr>
             <a:r>
               <a:rPr lang="en-US" sz="2400" b="1" dirty="0" smtClean="0"/>
-              <a:t>The gentiles might glorify God for His mercy </a:t>
-            </a:r>
-            <a:r>
-              <a:rPr lang="en-US" sz="2400" b="1" dirty="0" smtClean="0"/>
-              <a:t>   :       </a:t>
-            </a:r>
-            <a:r>
-              <a:rPr lang="en-US" sz="2400" b="1" dirty="0" smtClean="0"/>
-              <a:t>Rom </a:t>
-            </a:r>
-            <a:r>
-              <a:rPr lang="en-US" sz="2400" b="1" dirty="0" smtClean="0"/>
-              <a:t>15:9</a:t>
+              <a:t>The gentiles might glorify God for His mercy    :       Rom 15:9</a:t>
             </a:r>
           </a:p>
           <a:p>
@@ -7052,11 +7019,7 @@
             </a:pPr>
             <a:r>
               <a:rPr lang="en-US" sz="2400" b="1" dirty="0" smtClean="0"/>
-              <a:t>Example </a:t>
-            </a:r>
-            <a:r>
-              <a:rPr lang="en-US" sz="2400" b="1" dirty="0" smtClean="0"/>
-              <a:t>for holy life : Mathew 11:29 1John 2:6 1Peter 1:15,16 2:21</a:t>
+              <a:t>Example for holy life : Mathew 11:29 1John 2:6 1Peter 1:15,16 2:21</a:t>
             </a:r>
           </a:p>
           <a:p>
@@ -7076,11 +7039,7 @@
             </a:pPr>
             <a:r>
               <a:rPr lang="en-US" sz="2400" b="1" dirty="0" smtClean="0"/>
-              <a:t>Head </a:t>
-            </a:r>
-            <a:r>
-              <a:rPr lang="en-US" sz="2400" b="1" dirty="0" smtClean="0"/>
-              <a:t>of the new creation : 2Cor 5:17, Galatians 6:15</a:t>
+              <a:t>Head of the new creation : 2Cor 5:17, Galatians 6:15</a:t>
             </a:r>
           </a:p>
           <a:p>
@@ -7100,11 +7059,7 @@
             </a:pPr>
             <a:r>
               <a:rPr lang="en-US" sz="2400" b="1" dirty="0" smtClean="0"/>
-              <a:t>Christ shall be called the son of the Highest : Luke 1: </a:t>
-            </a:r>
-            <a:r>
-              <a:rPr lang="en-US" sz="2400" b="1" dirty="0" smtClean="0"/>
-              <a:t>32</a:t>
+              <a:t>Christ shall be called the son of the Highest : Luke 1: 32</a:t>
             </a:r>
           </a:p>
           <a:p>

</xml_diff>